<commit_message>
Update anti-vishing proposal presentation files
</commit_message>
<xml_diff>
--- a/slides/anti_vishing_proposal.pptx
+++ b/slides/anti_vishing_proposal.pptx
@@ -1686,10 +1686,14 @@
           <a:lstStyle/>
           <a:p>
             <a:r>
-              <a:rPr lang="en-US" dirty="0"/>
               <a:t>This slide answers the 'operational feasibility' requirement from the brief directly. Four levers: streaming windows instead of whole-call batch processing, compression to hit latency, training on degraded/codec/narrowband audio because real vishing calls are never studio-clean, and an edge/cloud split so the perceived latency stays low even though the full model runs heavier analysis asynchronously.</a:t>
             </a:r>
-            <a:endParaRPr lang="en-US" dirty="0"/>
+          </a:p>
+          <a:p/>
+          <a:p>
+            <a:r>
+              <a:t>Measured ourselves from the official ASVspoof 2021 baseline scores. RawNet2 by codec: none 5.84, u-law 6.33, G.722 6.41, a-law 6.59, Opus 7.95, GSM 10.66, PSTN 16.72 percent EER. Note a-law and u-law are 8 kHz narrowband yet beat wideband Opus, so the simple 'narrowband is the problem' story is wrong. G.711 only band-limits and keeps the waveform; GSM is a 13 kbps LPC vocoder and PSTN adds unknown repeated transcoding. That is what our augmentation has to cover.</a:t>
+            </a:r>
           </a:p>
         </p:txBody>
       </p:sp>
@@ -10670,15 +10674,13 @@
               <a:buNone/>
             </a:pPr>
             <a:r>
-              <a:rPr lang="en-US" sz="1200" dirty="0">
+              <a:rPr sz="1200">
                 <a:solidFill>
                   <a:srgbClr val="44506B"/>
                 </a:solidFill>
-                <a:latin typeface="Calibri" pitchFamily="34" charset="0"/>
-                <a:ea typeface="Calibri" pitchFamily="34" charset="-122"/>
-                <a:cs typeface="Calibri" pitchFamily="34" charset="-120"/>
-              </a:rPr>
-              <a:t>Train with codec compression, packet loss, and 8kHz narrowband telephony — the real conditions vishing calls arrive on.</a:t>
+                <a:latin typeface="Calibri"/>
+              </a:rPr>
+              <a:t>We measured the official baseline per codec: G.711 costs little (6.3%), but GSM hits 10.7% and uncontrolled PSTN transcoding 16.7%. Compression severity, not bandwidth, is what hurts.</a:t>
             </a:r>
             <a:endParaRPr lang="en-US" sz="1200" dirty="0"/>
           </a:p>

</xml_diff>

<commit_message>
Add novelty analysis document and update PDF versions
- Introduced a new markdown file `novelty.md` detailing the originality claims and findings related to modern telephony and generator evaluations.
- Added two new PDF documents: `2410.04324v3.pdf` and `2410.04324v4.pdf`, which contain relevant research updates.
</commit_message>
<xml_diff>
--- a/slides/anti_vishing_proposal.pptx
+++ b/slides/anti_vishing_proposal.pptx
@@ -1511,7 +1511,34 @@
           <a:p>
             <a:r>
               <a:rPr sz="1200"/>
-              <a:t>This is the single most important design decision in the deck. Traditional detectors overfit to known vocoders; SSL foundation models generalize better across generators without language-specific tuning. Everything downstream -- architecture, evaluation protocol -- follows from this bet.</a:t>
+              <a:t>This is the single most important design decision in the deck, and it now needs a caveat.</a:t>
+            </a:r>
+          </a:p>
+          <a:p/>
+          <a:p>
+            <a:r>
+              <a:rPr sz="1200"/>
+              <a:t>The claim: detectors trained from scratch overfit to the vocoders they saw. Foundation models generalise better. The source is SONAR, which is reading [1] from the brief, so say the name.</a:t>
+            </a:r>
+          </a:p>
+          <a:p>
+            <a:r>
+              <a:rPr sz="1200"/>
+              <a:t>Numbers if asked: on In-the-Wild, trained on Wavefake, Wav2Vec2BERT reaches 7.676% EER where AASIST is 27.277%, RawNet2 46.792% and LFCC-LCNN 99.2%, which is worse than guessing.</a:t>
+            </a:r>
+          </a:p>
+          <a:p/>
+          <a:p>
+            <a:r>
+              <a:rPr sz="1200"/>
+              <a:t>Now the caveat, and volunteer it rather than waiting to be caught. Delgado et al., ICASSP 2026, cloned voices with ElevenLabs, Play.ht and OpenAI Voice Engine and presented them into a real call-centre path at 8 kHz. There, a 3.55M-parameter logmel-ResNet matched WavLM Large, and beat it on real-world injection, 89.4% versus 88.2% detection at 1% false alarm.</a:t>
+            </a:r>
+          </a:p>
+          <a:p/>
+          <a:p>
+            <a:r>
+              <a:rPr sz="1200"/>
+              <a:t>Both results are true and they are about different axes. SONAR measures generalisation across generators. Delgado measures the real telephony path. Our deployment is the second one, so we treat the foundation-model choice as a hypothesis to test, not a settled bet. That is why on-device triage sits next to the heavy backbone in the systems slide.</a:t>
             </a:r>
           </a:p>
         </p:txBody>
@@ -1863,7 +1890,83 @@
         <p:txBody>
           <a:bodyPr/>
           <a:lstStyle/>
+          <a:p>
+            <a:r>
+              <a:rPr sz="1200"/>
+              <a:t>Evaluation has to prove generalization, not accuracy. Three things we track.</a:t>
+            </a:r>
+          </a:p>
           <a:p/>
+          <a:p>
+            <a:r>
+              <a:rPr sz="1200"/>
+              <a:t>EER and min t-DCF on held-out splits. Standard PAD metrics, not raw accuracy.</a:t>
+            </a:r>
+          </a:p>
+          <a:p/>
+          <a:p>
+            <a:r>
+              <a:rPr sz="1200"/>
+              <a:t>False alarms per call-minute, because a streaming detector is judged per call, not per window. Do</a:t>
+            </a:r>
+          </a:p>
+          <a:p>
+            <a:r>
+              <a:rPr sz="1200"/>
+              <a:t>the arithmetic out loud if asked: 5% per-window error, 2-second windows, 30 windows in a minute,</a:t>
+            </a:r>
+          </a:p>
+          <a:p>
+            <a:r>
+              <a:rPr sz="1200"/>
+              <a:t>one minus 0.95 to the 30th is 79%. Four calls in five would raise a false alarm. That is why</a:t>
+            </a:r>
+          </a:p>
+          <a:p>
+            <a:r>
+              <a:rPr sz="1200"/>
+              <a:t>per-window error is the wrong number to put on a slide.</a:t>
+            </a:r>
+          </a:p>
+          <a:p/>
+          <a:p>
+            <a:r>
+              <a:rPr sz="1200"/>
+              <a:t>Leave-one-generator-out. Whole vocoder and TTS families kept out of training, so cross-generator</a:t>
+            </a:r>
+          </a:p>
+          <a:p>
+            <a:r>
+              <a:rPr sz="1200"/>
+              <a:t>robustness is measured rather than assumed.</a:t>
+            </a:r>
+          </a:p>
+          <a:p/>
+          <a:p>
+            <a:r>
+              <a:rPr sz="1200"/>
+              <a:t>Every EER reported twice, with and without silence. ASVspoof 2021 ships a VAD-trimmed subset of</a:t>
+            </a:r>
+          </a:p>
+          <a:p>
+            <a:r>
+              <a:rPr sz="1200"/>
+              <a:t>16,926 trials, so this costs us nothing, and after slide 4 any expert in the room will ask for it.</a:t>
+            </a:r>
+          </a:p>
+          <a:p/>
+          <a:p>
+            <a:r>
+              <a:rPr sz="1200"/>
+              <a:t>The chart is where the time goes per 2-second chunk, not a promise. The alarm is read by a person,</a:t>
+            </a:r>
+          </a:p>
+          <a:p>
+            <a:r>
+              <a:rPr sz="1200"/>
+              <a:t>so the real budget is seconds. Per chunk we only have to keep up with the stream.</a:t>
+            </a:r>
+          </a:p>
         </p:txBody>
       </p:sp>
       <p:sp>
@@ -1947,10 +2050,80 @@
           <a:lstStyle/>
           <a:p>
             <a:r>
-              <a:rPr lang="en-US" dirty="0"/>
-              <a:t>Shows the panel this is a realistic two-day plan, not hand-waving. Day 1 gets a working generalization-tested baseline; Day 2 is where it becomes real-time and gets wired into the multi-layer story, leaving real time to rehearse before this exact presentation.</a:t>
-            </a:r>
-            <a:endParaRPr lang="en-US" dirty="0"/>
+              <a:rPr sz="1200"/>
+              <a:t>Keep this short. It exists so the panel knows the timeline is real.</a:t>
+            </a:r>
+          </a:p>
+          <a:p/>
+          <a:p>
+            <a:r>
+              <a:rPr sz="1200"/>
+              <a:t>The 2-day sprint is this deck: survey the generalization failure, fix the evaluation protocol,</a:t>
+            </a:r>
+          </a:p>
+          <a:p>
+            <a:r>
+              <a:rPr sz="1200"/>
+              <a:t>commit to an architecture. We are not claiming to have built a system in two days.</a:t>
+            </a:r>
+          </a:p>
+          <a:p/>
+          <a:p>
+            <a:r>
+              <a:rPr sz="1200"/>
+              <a:t>Weeks 2 to 4, baseline. Reproduce the published clean-condition EER. We can already validate our</a:t>
+            </a:r>
+          </a:p>
+          <a:p>
+            <a:r>
+              <a:rPr sz="1200"/>
+              <a:t>evaluation code against the official baseline score files that ship with the challenge keys, so if</a:t>
+            </a:r>
+          </a:p>
+          <a:p>
+            <a:r>
+              <a:rPr sz="1200"/>
+              <a:t>our number does not match, the bug is ours and we find it in week 3 rather than week 10.</a:t>
+            </a:r>
+          </a:p>
+          <a:p/>
+          <a:p>
+            <a:r>
+              <a:rPr sz="1200"/>
+              <a:t>Weeks 5 to 9 are the core. Degraded-channel and silence augmentation, the foundation-model</a:t>
+            </a:r>
+          </a:p>
+          <a:p>
+            <a:r>
+              <a:rPr sz="1200"/>
+              <a:t>front-end, leave-one-generator-out. This is where the gap closes or it does not.</a:t>
+            </a:r>
+          </a:p>
+          <a:p/>
+          <a:p>
+            <a:r>
+              <a:rPr sz="1200"/>
+              <a:t>Weeks 10 to 12, streaming inference, compression, latency on the device, then the report.</a:t>
+            </a:r>
+          </a:p>
+          <a:p/>
+          <a:p>
+            <a:r>
+              <a:rPr sz="1200"/>
+              <a:t>Say the risk out loud: weeks 5 to 9 are where we expect to slip. Building an augmentation pipeline</a:t>
+            </a:r>
+          </a:p>
+          <a:p>
+            <a:r>
+              <a:rPr sz="1200"/>
+              <a:t>and chasing generalization both historically overrun. Compute is one 16 GB laptop GPU at roughly</a:t>
+            </a:r>
+          </a:p>
+          <a:p>
+            <a:r>
+              <a:rPr sz="1200"/>
+              <a:t>1.5 to 3 hours per training run, which serialises the experiments.</a:t>
+            </a:r>
           </a:p>
         </p:txBody>
       </p:sp>
@@ -4416,7 +4589,7 @@
                 </a:solidFill>
                 <a:latin typeface="Calibri"/>
               </a:rPr>
-              <a:t>A short sprint limits how much training data we can cover compared with production scale.</a:t>
+              <a:t>Telephony PAD is not new ground. ASVspoof 5 and Delgado et al. (ICASSP 2026) already cover 2023-24 generators at 8 kHz. Our scope is the open-source 2024-26 models they do not include.</a:t>
             </a:r>
             <a:endParaRPr lang="en-US" sz="1250" dirty="0"/>
           </a:p>
@@ -9197,6 +9370,48 @@
           </a:p>
         </p:txBody>
       </p:sp>
+      <p:sp>
+        <p:nvSpPr>
+          <p:cNvPr id="19" name="TextBox 18"/>
+          <p:cNvSpPr txBox="1"/>
+          <p:nvPr/>
+        </p:nvSpPr>
+        <p:spPr>
+          <a:xfrm>
+            <a:off x="548640" y="6025896"/>
+            <a:ext cx="11091672" cy="502920"/>
+          </a:xfrm>
+          <a:prstGeom prst="rect">
+            <a:avLst/>
+          </a:prstGeom>
+          <a:noFill/>
+        </p:spPr>
+        <p:txBody>
+          <a:bodyPr wrap="square" lIns="0" rIns="0" tIns="0" bIns="0">
+            <a:spAutoFit/>
+          </a:bodyPr>
+          <a:lstStyle/>
+          <a:p>
+            <a:pPr>
+              <a:lnSpc>
+                <a:spcPct val="125000"/>
+              </a:lnSpc>
+              <a:spcAft>
+                <a:spcPts val="0"/>
+              </a:spcAft>
+            </a:pPr>
+            <a:r>
+              <a:rPr sz="1100" i="1">
+                <a:solidFill>
+                  <a:srgbClr val="8792AC"/>
+                </a:solidFill>
+                <a:latin typeface="Calibri"/>
+              </a:rPr>
+              <a:t>Comparison from SONAR (Li, Chen &amp; Wei, 2024). The caveat we have to carry: at 8 kHz over a real call-centre path, a 3.55M-parameter model matched WavLM Large (Delgado et al., ICASSP 2026). Which holds for us is an open question we intend to measure, not assume.</a:t>
+            </a:r>
+          </a:p>
+        </p:txBody>
+      </p:sp>
     </p:spTree>
   </p:cSld>
   <p:clrMapOvr>
@@ -10680,7 +10895,7 @@
                 </a:solidFill>
                 <a:latin typeface="Calibri"/>
               </a:rPr>
-              <a:t>We measured the official baseline per codec: G.711 costs little (6.3%), but GSM hits 10.7% and uncontrolled PSTN transcoding 16.7%. Compression severity, not bandwidth, is what hurts.</a:t>
+              <a:t>We measured the official baseline ourselves: PSTN transcoding costs 16.7% EER where clean audio costs 5.8%. Codec augmentation is the known fix. Published wav2vec2 goes from 19.09% to 0.56% on PSTN with RawBoost.</a:t>
             </a:r>
             <a:endParaRPr lang="en-US" sz="1200" dirty="0"/>
           </a:p>

</xml_diff>